<commit_message>
Rename field program education to on-site AX workshop in slide 4
Co-Authored-By: Claude Opus 5.5 <noreply@anthropic.com>
Claude-Session: https://claude.ai/code/session_014bmYQ2fMPYk9mSnunBW5W4
</commit_message>
<xml_diff>
--- a/27_중점과제_AX변화관리_사업화.pptx
+++ b/27_중점과제_AX변화관리_사업화.pptx
@@ -1929,112 +1929,7 @@
         </p:nvSpPr>
         <p:spPr>
           <a:xfrm>
-            <a:off x="594360" y="4443984"/>
-            <a:ext cx="5303520" cy="256032"/>
-          </a:xfrm>
-          <a:prstGeom prst="rect">
-            <a:avLst/>
-          </a:prstGeom>
-          <a:noFill/>
-          <a:ln/>
-        </p:spPr>
-        <p:txBody>
-          <a:bodyPr wrap="square" lIns="0" tIns="0" rIns="0" bIns="0" rtlCol="0" anchor="ctr"/>
-          <a:lstStyle/>
-          <a:p>
-            <a:pPr indent="0" marL="0">
-              <a:buNone/>
-            </a:pPr>
-            <a:r>
-              <a:rPr lang="en-US" sz="1150" b="1" dirty="0">
-                <a:solidFill>
-                  <a:srgbClr val="262626"/>
-                </a:solidFill>
-              </a:rPr>
-              <a:t>•  </a:t>
-            </a:r>
-            <a:pPr indent="0" marL="0">
-              <a:buNone/>
-            </a:pPr>
-            <a:r>
-              <a:rPr lang="en-US" sz="1150" b="1" dirty="0">
-                <a:solidFill>
-                  <a:srgbClr val="262626"/>
-                </a:solidFill>
-              </a:rPr>
-              <a:t>교육 현장이 </a:t>
-            </a:r>
-            <a:pPr indent="0" marL="0">
-              <a:buNone/>
-            </a:pPr>
-            <a:r>
-              <a:rPr lang="en-US" sz="1150" b="1" dirty="0">
-                <a:solidFill>
-                  <a:srgbClr val="1F3FA8"/>
-                </a:solidFill>
-              </a:rPr>
-              <a:t>AI 니즈 발굴 창구</a:t>
-            </a:r>
-            <a:pPr indent="0" marL="0">
-              <a:buNone/>
-            </a:pPr>
-            <a:r>
-              <a:rPr lang="en-US" sz="1150" b="1" dirty="0">
-                <a:solidFill>
-                  <a:srgbClr val="262626"/>
-                </a:solidFill>
-              </a:rPr>
-              <a:t> → 과제화·사업 기회로 연결</a:t>
-            </a:r>
-            <a:endParaRPr lang="en-US" sz="1150" dirty="0"/>
-          </a:p>
-        </p:txBody>
-      </p:sp>
-      <p:sp>
-        <p:nvSpPr>
-          <p:cNvPr id="16" name="Text 13"/>
-          <p:cNvSpPr txBox="1"/>
-          <p:nvPr/>
-        </p:nvSpPr>
-        <p:spPr>
-          <a:xfrm>
-            <a:off x="822960" y="4718304"/>
-            <a:ext cx="5074920" cy="219456"/>
-          </a:xfrm>
-          <a:prstGeom prst="rect">
-            <a:avLst/>
-          </a:prstGeom>
-          <a:noFill/>
-          <a:ln/>
-        </p:spPr>
-        <p:txBody>
-          <a:bodyPr wrap="square" lIns="0" tIns="0" rIns="0" bIns="0" rtlCol="0" anchor="ctr"/>
-          <a:lstStyle/>
-          <a:p>
-            <a:pPr indent="0" marL="0">
-              <a:buNone/>
-            </a:pPr>
-            <a:r>
-              <a:rPr lang="en-US" sz="1050" b="1" dirty="0">
-                <a:solidFill>
-                  <a:srgbClr val="262626"/>
-                </a:solidFill>
-              </a:rPr>
-              <a:t>- 백화점 이커머스 실무자 교육('26.10)에서 현업 AI 요구사항 직접 수집</a:t>
-            </a:r>
-            <a:endParaRPr lang="en-US" sz="1050" dirty="0"/>
-          </a:p>
-        </p:txBody>
-      </p:sp>
-      <p:sp>
-        <p:nvSpPr>
-          <p:cNvPr id="17" name="Text 14"/>
-          <p:cNvSpPr txBox="1"/>
-          <p:nvPr/>
-        </p:nvSpPr>
-        <p:spPr>
-          <a:xfrm>
-            <a:off x="411480" y="5029200"/>
+            <a:off x="411480" y="4617720"/>
             <a:ext cx="2670048" cy="292608"/>
           </a:xfrm>
           <a:prstGeom prst="rect">
@@ -2058,13 +1953,13 @@
       </p:sp>
       <p:sp>
         <p:nvSpPr>
-          <p:cNvPr id="18" name="번호 1"/>
+          <p:cNvPr id="16" name="번호 1"/>
           <p:cNvSpPr/>
           <p:nvPr/>
         </p:nvSpPr>
         <p:spPr>
           <a:xfrm>
-            <a:off x="484632" y="5074920"/>
+            <a:off x="484632" y="4663440"/>
             <a:ext cx="201168" cy="201168"/>
           </a:xfrm>
           <a:prstGeom prst="ellipse">
@@ -2083,13 +1978,13 @@
       </p:sp>
       <p:sp>
         <p:nvSpPr>
-          <p:cNvPr id="19" name="Text 16"/>
+          <p:cNvPr id="17" name="Text 14"/>
           <p:cNvSpPr txBox="1"/>
           <p:nvPr/>
         </p:nvSpPr>
         <p:spPr>
           <a:xfrm>
-            <a:off x="484632" y="5074920"/>
+            <a:off x="484632" y="4663440"/>
             <a:ext cx="201168" cy="201168"/>
           </a:xfrm>
           <a:prstGeom prst="rect">
@@ -2119,13 +2014,13 @@
       </p:sp>
       <p:sp>
         <p:nvSpPr>
-          <p:cNvPr id="20" name="Text 17"/>
+          <p:cNvPr id="18" name="Text 15"/>
           <p:cNvSpPr txBox="1"/>
           <p:nvPr/>
         </p:nvSpPr>
         <p:spPr>
           <a:xfrm>
-            <a:off x="740664" y="5029200"/>
+            <a:off x="740664" y="4617720"/>
             <a:ext cx="2304288" cy="292608"/>
           </a:xfrm>
           <a:prstGeom prst="rect">
@@ -2147,7 +2042,7 @@
                   <a:srgbClr val="262626"/>
                 </a:solidFill>
               </a:rPr>
-              <a:t>그룹 공통 AI 프로그램</a:t>
+              <a:t>그룹 공통 AI 교육</a:t>
             </a:r>
             <a:endParaRPr lang="en-US" sz="1150" dirty="0"/>
           </a:p>
@@ -2155,13 +2050,13 @@
       </p:sp>
       <p:sp>
         <p:nvSpPr>
-          <p:cNvPr id="21" name="박스 1"/>
+          <p:cNvPr id="19" name="박스 1"/>
           <p:cNvSpPr txBox="1"/>
           <p:nvPr/>
         </p:nvSpPr>
         <p:spPr>
           <a:xfrm>
-            <a:off x="411480" y="5321808"/>
+            <a:off x="411480" y="4910328"/>
             <a:ext cx="2670048" cy="566928"/>
           </a:xfrm>
           <a:prstGeom prst="rect">
@@ -2211,13 +2106,13 @@
       </p:sp>
       <p:sp>
         <p:nvSpPr>
-          <p:cNvPr id="22" name="Text 19"/>
+          <p:cNvPr id="20" name="Text 17"/>
           <p:cNvSpPr txBox="1"/>
           <p:nvPr/>
         </p:nvSpPr>
         <p:spPr>
           <a:xfrm>
-            <a:off x="3264408" y="5029200"/>
+            <a:off x="3264408" y="4617720"/>
             <a:ext cx="2670048" cy="292608"/>
           </a:xfrm>
           <a:prstGeom prst="rect">
@@ -2241,13 +2136,13 @@
       </p:sp>
       <p:sp>
         <p:nvSpPr>
-          <p:cNvPr id="23" name="번호 2"/>
+          <p:cNvPr id="21" name="번호 2"/>
           <p:cNvSpPr/>
           <p:nvPr/>
         </p:nvSpPr>
         <p:spPr>
           <a:xfrm>
-            <a:off x="3337560" y="5074920"/>
+            <a:off x="3337560" y="4663440"/>
             <a:ext cx="201168" cy="201168"/>
           </a:xfrm>
           <a:prstGeom prst="ellipse">
@@ -2266,13 +2161,13 @@
       </p:sp>
       <p:sp>
         <p:nvSpPr>
-          <p:cNvPr id="24" name="Text 21"/>
+          <p:cNvPr id="22" name="Text 19"/>
           <p:cNvSpPr txBox="1"/>
           <p:nvPr/>
         </p:nvSpPr>
         <p:spPr>
           <a:xfrm>
-            <a:off x="3337560" y="5074920"/>
+            <a:off x="3337560" y="4663440"/>
             <a:ext cx="201168" cy="201168"/>
           </a:xfrm>
           <a:prstGeom prst="rect">
@@ -2302,13 +2197,13 @@
       </p:sp>
       <p:sp>
         <p:nvSpPr>
-          <p:cNvPr id="25" name="Text 22"/>
+          <p:cNvPr id="23" name="Text 20"/>
           <p:cNvSpPr txBox="1"/>
           <p:nvPr/>
         </p:nvSpPr>
         <p:spPr>
           <a:xfrm>
-            <a:off x="3593592" y="5029200"/>
+            <a:off x="3593592" y="4617720"/>
             <a:ext cx="2304288" cy="292608"/>
           </a:xfrm>
           <a:prstGeom prst="rect">
@@ -2338,13 +2233,13 @@
       </p:sp>
       <p:sp>
         <p:nvSpPr>
-          <p:cNvPr id="26" name="박스 2"/>
+          <p:cNvPr id="24" name="박스 2"/>
           <p:cNvSpPr txBox="1"/>
           <p:nvPr/>
         </p:nvSpPr>
         <p:spPr>
           <a:xfrm>
-            <a:off x="3264408" y="5321808"/>
+            <a:off x="3264408" y="4910328"/>
             <a:ext cx="2670048" cy="566928"/>
           </a:xfrm>
           <a:prstGeom prst="rect">
@@ -2372,7 +2267,7 @@
                   <a:srgbClr val="262626"/>
                 </a:solidFill>
               </a:rPr>
-              <a:t>현업 교육으로 AI 요구사항 수집</a:t>
+              <a:t>현장 맞춤 워크숍으로 AI 니즈 수집</a:t>
             </a:r>
             <a:endParaRPr lang="en-US" sz="1050" dirty="0"/>
           </a:p>
@@ -2394,14 +2289,14 @@
       </p:sp>
       <p:sp>
         <p:nvSpPr>
-          <p:cNvPr id="27" name="환류선"/>
+          <p:cNvPr id="25" name="환류선"/>
           <p:cNvSpPr/>
           <p:nvPr/>
         </p:nvSpPr>
         <p:spPr>
           <a:xfrm>
-            <a:off x="4599432" y="5888736"/>
-            <a:ext cx="0" cy="219456"/>
+            <a:off x="4599432" y="5477256"/>
+            <a:ext cx="0" cy="283464"/>
           </a:xfrm>
           <a:prstGeom prst="line">
             <a:avLst/>
@@ -2417,13 +2312,13 @@
       </p:sp>
       <p:sp>
         <p:nvSpPr>
-          <p:cNvPr id="28" name="환류선"/>
+          <p:cNvPr id="26" name="환류선"/>
           <p:cNvSpPr/>
           <p:nvPr/>
         </p:nvSpPr>
         <p:spPr>
           <a:xfrm>
-            <a:off x="1746504" y="6108192"/>
+            <a:off x="1746504" y="5760720"/>
             <a:ext cx="2852928" cy="0"/>
           </a:xfrm>
           <a:prstGeom prst="line">
@@ -2440,14 +2335,14 @@
       </p:sp>
       <p:sp>
         <p:nvSpPr>
-          <p:cNvPr id="29" name="환류선"/>
+          <p:cNvPr id="27" name="환류선"/>
           <p:cNvSpPr/>
           <p:nvPr/>
         </p:nvSpPr>
         <p:spPr>
           <a:xfrm>
-            <a:off x="1746504" y="5888736"/>
-            <a:ext cx="0" cy="219456"/>
+            <a:off x="1746504" y="5477256"/>
+            <a:ext cx="0" cy="283464"/>
           </a:xfrm>
           <a:prstGeom prst="line">
             <a:avLst/>
@@ -2464,13 +2359,13 @@
       </p:sp>
       <p:sp>
         <p:nvSpPr>
-          <p:cNvPr id="30" name="환류 라벨"/>
+          <p:cNvPr id="28" name="환류 라벨"/>
           <p:cNvSpPr txBox="1"/>
           <p:nvPr/>
         </p:nvSpPr>
         <p:spPr>
           <a:xfrm>
-            <a:off x="2020824" y="6099048"/>
+            <a:off x="2020824" y="5751576"/>
             <a:ext cx="2304288" cy="237744"/>
           </a:xfrm>
           <a:prstGeom prst="rect">
@@ -2502,7 +2397,7 @@
       </p:sp>
       <p:sp>
         <p:nvSpPr>
-          <p:cNvPr id="31" name="머리표"/>
+          <p:cNvPr id="29" name="머리표"/>
           <p:cNvSpPr/>
           <p:nvPr/>
         </p:nvSpPr>
@@ -2534,7 +2429,7 @@
       </p:sp>
       <p:sp>
         <p:nvSpPr>
-          <p:cNvPr id="32" name="Text 29"/>
+          <p:cNvPr id="30" name="Text 27"/>
           <p:cNvSpPr txBox="1"/>
           <p:nvPr/>
         </p:nvSpPr>
@@ -2562,7 +2457,7 @@
                   <a:srgbClr val="262626"/>
                 </a:solidFill>
               </a:rPr>
-              <a:t>그룹 공통 AI 프로그램 (가칭 Lotte AX Academy)</a:t>
+              <a:t>그룹 공통 AI 교육 (가칭 Lotte AX Academy)</a:t>
             </a:r>
             <a:endParaRPr lang="en-US" sz="1300" dirty="0"/>
           </a:p>
@@ -2570,7 +2465,7 @@
       </p:sp>
       <p:sp>
         <p:nvSpPr>
-          <p:cNvPr id="33" name="Text 30"/>
+          <p:cNvPr id="31" name="Text 28"/>
           <p:cNvSpPr txBox="1"/>
           <p:nvPr/>
         </p:nvSpPr>
@@ -3144,7 +3039,7 @@
       </p:graphicFrame>
       <p:sp>
         <p:nvSpPr>
-          <p:cNvPr id="35" name="머리표"/>
+          <p:cNvPr id="33" name="머리표"/>
           <p:cNvSpPr/>
           <p:nvPr/>
         </p:nvSpPr>
@@ -3176,7 +3071,7 @@
       </p:sp>
       <p:sp>
         <p:nvSpPr>
-          <p:cNvPr id="36" name="Text 32"/>
+          <p:cNvPr id="34" name="Text 30"/>
           <p:cNvSpPr txBox="1"/>
           <p:nvPr/>
         </p:nvSpPr>
@@ -3212,7 +3107,7 @@
       </p:sp>
       <p:sp>
         <p:nvSpPr>
-          <p:cNvPr id="37" name="Text 33"/>
+          <p:cNvPr id="35" name="Text 31"/>
           <p:cNvSpPr txBox="1"/>
           <p:nvPr/>
         </p:nvSpPr>
@@ -3251,7 +3146,7 @@
                   <a:srgbClr val="262626"/>
                 </a:solidFill>
               </a:rPr>
-              <a:t>현업 AI 니즈를 과제화하여 </a:t>
+              <a:t>현업 AI 니즈 과제화를 통한 </a:t>
             </a:r>
             <a:pPr indent="0" marL="0">
               <a:buNone/>
@@ -3262,7 +3157,7 @@
                   <a:srgbClr val="1F3FA8"/>
                 </a:solidFill>
               </a:rPr>
-              <a:t>그룹사 선제안·사업화까지 연계</a:t>
+              <a:t>그룹사 선제안·사업화 연계</a:t>
             </a:r>
             <a:endParaRPr lang="en-US" sz="1100" dirty="0"/>
           </a:p>
@@ -3450,7 +3345,28 @@
                           <a:ea typeface="맑은 고딕" pitchFamily="34" charset="-122"/>
                           <a:cs typeface="맑은 고딕" pitchFamily="34" charset="-120"/>
                         </a:rPr>
-                        <a:t>AX Inno Camp</a:t>
+                        <a:t>현장 맞춤</a:t>
+                      </a:r>
+                      <a:endParaRPr lang="en-US" sz="1000" dirty="0">
+                        <a:latin typeface="맑은 고딕" charset="0"/>
+                        <a:ea typeface="맑은 고딕" charset="0"/>
+                        <a:cs typeface="맑은 고딕" charset="0"/>
+                      </a:endParaRPr>
+                    </a:p>
+                    <a:p>
+                      <a:pPr algn="ctr" indent="0" marL="0">
+                        <a:buNone/>
+                      </a:pPr>
+                      <a:r>
+                        <a:rPr lang="en-US" sz="1000" b="1" dirty="0">
+                          <a:solidFill>
+                            <a:srgbClr val="262626"/>
+                          </a:solidFill>
+                          <a:latin typeface="맑은 고딕" pitchFamily="34" charset="0"/>
+                          <a:ea typeface="맑은 고딕" pitchFamily="34" charset="-122"/>
+                          <a:cs typeface="맑은 고딕" pitchFamily="34" charset="-120"/>
+                        </a:rPr>
+                        <a:t>AX 워크숍</a:t>
                       </a:r>
                       <a:endParaRPr lang="en-US" sz="1000" dirty="0">
                         <a:latin typeface="맑은 고딕" charset="0"/>
@@ -3515,7 +3431,7 @@
                           <a:ea typeface="맑은 고딕" pitchFamily="34" charset="-122"/>
                           <a:cs typeface="맑은 고딕" pitchFamily="34" charset="-120"/>
                         </a:rPr>
-                        <a:t>현업 참여 기반 實데이터로 Agent 기획 및 구현</a:t>
+                        <a:t>현업 참여·實데이터 기반 AI 과제 발굴</a:t>
                       </a:r>
                       <a:endParaRPr lang="en-US" sz="1000" dirty="0">
                         <a:latin typeface="맑은 고딕" charset="0"/>
@@ -3536,7 +3452,7 @@
                           <a:ea typeface="맑은 고딕" pitchFamily="34" charset="-122"/>
                           <a:cs typeface="맑은 고딕" pitchFamily="34" charset="-120"/>
                         </a:rPr>
-                        <a:t>(사례) 백화점 이커머스 ('26.10) : 실무자 AI 과제 도출 교육</a:t>
+                        <a:t>(사례) 백화점 이커머스 ('26.10) : 실무자 AI 실습·과제 도출 워크숍</a:t>
                       </a:r>
                       <a:endParaRPr lang="en-US" sz="1000" dirty="0">
                         <a:latin typeface="맑은 고딕" charset="0"/>
@@ -3668,7 +3584,7 @@
                           <a:ea typeface="맑은 고딕" pitchFamily="34" charset="-122"/>
                           <a:cs typeface="맑은 고딕" pitchFamily="34" charset="-120"/>
                         </a:rPr>
-                        <a:t>Camp 요구사항 선별 → </a:t>
+                        <a:t>워크숍 도출 과제 선별 → </a:t>
                       </a:r>
                       <a:pPr indent="0" marL="0">
                         <a:buNone/>
@@ -3682,7 +3598,7 @@
                           <a:ea typeface="맑은 고딕" pitchFamily="34" charset="-122"/>
                           <a:cs typeface="맑은 고딕" pitchFamily="34" charset="-120"/>
                         </a:rPr>
-                        <a:t>FDE 과제 선제안 → 구축사업 연계</a:t>
+                        <a:t>FDE 선제안 → 구축사업 연계</a:t>
                       </a:r>
                       <a:endParaRPr lang="en-US" sz="1000" dirty="0">
                         <a:latin typeface="맑은 고딕" charset="0"/>

</xml_diff>

<commit_message>
Refine slide 4 governing message and right-side wording
Co-Authored-By: Claude Opus 5.5 <noreply@anthropic.com>
Claude-Session: https://claude.ai/code/session_014bmYQ2fMPYk9mSnunBW5W4
</commit_message>
<xml_diff>
--- a/27_중점과제_AX변화관리_사업화.pptx
+++ b/27_중점과제_AX변화관리_사업화.pptx
@@ -1078,7 +1078,7 @@
                   <a:srgbClr val="262626"/>
                 </a:solidFill>
               </a:rPr>
-              <a:t>인재개발원과 그룹 공통 AX 교육 체계를 마련하고, 현장 AI 니즈 과제화로 신규 사업 발굴</a:t>
+              <a:t>인재개발원과 그룹 공통 AX 교육 체계를 마련하고, 현장 맞춤 워크숍으로 그룹사 AX 사업 발굴</a:t>
             </a:r>
             <a:endParaRPr lang="en-US" sz="1600" dirty="0"/>
           </a:p>
@@ -1202,7 +1202,7 @@
                   <a:srgbClr val="FFFFFF"/>
                 </a:solidFill>
               </a:rPr>
-              <a:t>AX 변화관리 방안</a:t>
+              <a:t>AX 변화관리 및 사업화 방안</a:t>
             </a:r>
             <a:endParaRPr lang="en-US" sz="1500" dirty="0"/>
           </a:p>
@@ -2225,7 +2225,7 @@
                   <a:srgbClr val="262626"/>
                 </a:solidFill>
               </a:rPr>
-              <a:t>현장 AI 니즈 과제화</a:t>
+              <a:t>현장 맞춤 AX 워크숍</a:t>
             </a:r>
             <a:endParaRPr lang="en-US" sz="1150" dirty="0"/>
           </a:p>
@@ -2488,7 +2488,7 @@
               <a:buNone/>
             </a:pPr>
             <a:r>
-              <a:rPr lang="en-US" sz="1100" b="1" dirty="0">
+              <a:rPr lang="en-US" sz="1050" b="1" dirty="0">
                 <a:solidFill>
                   <a:srgbClr val="262626"/>
                 </a:solidFill>
@@ -2499,7 +2499,7 @@
               <a:buNone/>
             </a:pPr>
             <a:r>
-              <a:rPr lang="en-US" sz="1100" b="1" dirty="0">
+              <a:rPr lang="en-US" sz="1050" b="1" dirty="0">
                 <a:solidFill>
                   <a:srgbClr val="262626"/>
                 </a:solidFill>
@@ -2510,14 +2510,25 @@
               <a:buNone/>
             </a:pPr>
             <a:r>
-              <a:rPr lang="en-US" sz="1100" b="1" dirty="0">
+              <a:rPr lang="en-US" sz="1050" b="1" dirty="0">
                 <a:solidFill>
                   <a:srgbClr val="1F3FA8"/>
                 </a:solidFill>
               </a:rPr>
-              <a:t>AX컨설팅팀 맞춤 콘텐츠·실습 시나리오 제공</a:t>
-            </a:r>
-            <a:endParaRPr lang="en-US" sz="1100" dirty="0"/>
+              <a:t>AX컨설팅팀 맞춤 콘텐츠·시나리오 공급</a:t>
+            </a:r>
+            <a:pPr indent="0" marL="0">
+              <a:buNone/>
+            </a:pPr>
+            <a:r>
+              <a:rPr lang="en-US" sz="1050" b="1" dirty="0">
+                <a:solidFill>
+                  <a:srgbClr val="262626"/>
+                </a:solidFill>
+              </a:rPr>
+              <a:t> (콘텐츠 사업화)</a:t>
+            </a:r>
+            <a:endParaRPr lang="en-US" sz="1050" dirty="0"/>
           </a:p>
         </p:txBody>
       </p:sp>
@@ -3099,7 +3110,7 @@
                   <a:srgbClr val="262626"/>
                 </a:solidFill>
               </a:rPr>
-              <a:t>현장 AI 니즈 과제화</a:t>
+              <a:t>현장 맞춤 AX 워크숍</a:t>
             </a:r>
             <a:endParaRPr lang="en-US" sz="1300" dirty="0"/>
           </a:p>
@@ -3345,28 +3356,7 @@
                           <a:ea typeface="맑은 고딕" pitchFamily="34" charset="-122"/>
                           <a:cs typeface="맑은 고딕" pitchFamily="34" charset="-120"/>
                         </a:rPr>
-                        <a:t>현장 맞춤</a:t>
-                      </a:r>
-                      <a:endParaRPr lang="en-US" sz="1000" dirty="0">
-                        <a:latin typeface="맑은 고딕" charset="0"/>
-                        <a:ea typeface="맑은 고딕" charset="0"/>
-                        <a:cs typeface="맑은 고딕" charset="0"/>
-                      </a:endParaRPr>
-                    </a:p>
-                    <a:p>
-                      <a:pPr algn="ctr" indent="0" marL="0">
-                        <a:buNone/>
-                      </a:pPr>
-                      <a:r>
-                        <a:rPr lang="en-US" sz="1000" b="1" dirty="0">
-                          <a:solidFill>
-                            <a:srgbClr val="262626"/>
-                          </a:solidFill>
-                          <a:latin typeface="맑은 고딕" pitchFamily="34" charset="0"/>
-                          <a:ea typeface="맑은 고딕" pitchFamily="34" charset="-122"/>
-                          <a:cs typeface="맑은 고딕" pitchFamily="34" charset="-120"/>
-                        </a:rPr>
-                        <a:t>AX 워크숍</a:t>
+                        <a:t>현장 워크숍</a:t>
                       </a:r>
                       <a:endParaRPr lang="en-US" sz="1000" dirty="0">
                         <a:latin typeface="맑은 고딕" charset="0"/>
@@ -3431,7 +3421,7 @@
                           <a:ea typeface="맑은 고딕" pitchFamily="34" charset="-122"/>
                           <a:cs typeface="맑은 고딕" pitchFamily="34" charset="-120"/>
                         </a:rPr>
-                        <a:t>현업 참여·實데이터 기반 AI 과제 발굴</a:t>
+                        <a:t>현업 참여·데이터 기반 AI 과제 발굴</a:t>
                       </a:r>
                       <a:endParaRPr lang="en-US" sz="1000" dirty="0">
                         <a:latin typeface="맑은 고딕" charset="0"/>
@@ -3452,7 +3442,7 @@
                           <a:ea typeface="맑은 고딕" pitchFamily="34" charset="-122"/>
                           <a:cs typeface="맑은 고딕" pitchFamily="34" charset="-120"/>
                         </a:rPr>
-                        <a:t>(사례) 백화점 이커머스 ('26.10) : 실무자 AI 실습·과제 도출 워크숍</a:t>
+                        <a:t>(사례) 백화점 이커머스 : 실무자 AI 실습·과제 도출 워크숍 ('26.10)</a:t>
                       </a:r>
                       <a:endParaRPr lang="en-US" sz="1000" dirty="0">
                         <a:latin typeface="맑은 고딕" charset="0"/>

</xml_diff>